<commit_message>
update presentation file with new content
</commit_message>
<xml_diff>
--- a/BaoCao/kl-da22ttc-nguyenhuynhphuvinh-110122203-linvnix.pptx
+++ b/BaoCao/kl-da22ttc-nguyenhuynhphuvinh-110122203-linvnix.pptx
@@ -228,7 +228,7 @@
             <a:fld id="{3EFD42F7-718C-4B98-AAEC-167E6DDD60A7}" type="datetimeFigureOut">
               <a:rPr lang="en-US" smtClean="0"/>
               <a:pPr/>
-              <a:t>7/6/2026</a:t>
+              <a:t>7/7/2026</a:t>
             </a:fld>
             <a:endParaRPr lang="en-US" dirty="0"/>
           </a:p>
@@ -625,7 +625,7 @@
           <a:p>
             <a:fld id="{1D8BD707-D9CF-40AE-B4C6-C98DA3205C09}" type="datetimeFigureOut">
               <a:rPr lang="en-US" smtClean="0"/>
-              <a:t>7/6/2026</a:t>
+              <a:t>7/7/2026</a:t>
             </a:fld>
             <a:endParaRPr lang="en-US"/>
           </a:p>
@@ -823,7 +823,7 @@
           <a:p>
             <a:fld id="{1D8BD707-D9CF-40AE-B4C6-C98DA3205C09}" type="datetimeFigureOut">
               <a:rPr lang="en-US" smtClean="0"/>
-              <a:t>7/6/2026</a:t>
+              <a:t>7/7/2026</a:t>
             </a:fld>
             <a:endParaRPr lang="en-US"/>
           </a:p>
@@ -1031,7 +1031,7 @@
           <a:p>
             <a:fld id="{1D8BD707-D9CF-40AE-B4C6-C98DA3205C09}" type="datetimeFigureOut">
               <a:rPr lang="en-US" smtClean="0"/>
-              <a:t>7/6/2026</a:t>
+              <a:t>7/7/2026</a:t>
             </a:fld>
             <a:endParaRPr lang="en-US"/>
           </a:p>
@@ -1229,7 +1229,7 @@
           <a:p>
             <a:fld id="{1D8BD707-D9CF-40AE-B4C6-C98DA3205C09}" type="datetimeFigureOut">
               <a:rPr lang="en-US" smtClean="0"/>
-              <a:t>7/6/2026</a:t>
+              <a:t>7/7/2026</a:t>
             </a:fld>
             <a:endParaRPr lang="en-US"/>
           </a:p>
@@ -1504,7 +1504,7 @@
           <a:p>
             <a:fld id="{1D8BD707-D9CF-40AE-B4C6-C98DA3205C09}" type="datetimeFigureOut">
               <a:rPr lang="en-US" smtClean="0"/>
-              <a:t>7/6/2026</a:t>
+              <a:t>7/7/2026</a:t>
             </a:fld>
             <a:endParaRPr lang="en-US"/>
           </a:p>
@@ -1769,7 +1769,7 @@
           <a:p>
             <a:fld id="{1D8BD707-D9CF-40AE-B4C6-C98DA3205C09}" type="datetimeFigureOut">
               <a:rPr lang="en-US" smtClean="0"/>
-              <a:t>7/6/2026</a:t>
+              <a:t>7/7/2026</a:t>
             </a:fld>
             <a:endParaRPr lang="en-US"/>
           </a:p>
@@ -2181,7 +2181,7 @@
           <a:p>
             <a:fld id="{1D8BD707-D9CF-40AE-B4C6-C98DA3205C09}" type="datetimeFigureOut">
               <a:rPr lang="en-US" smtClean="0"/>
-              <a:t>7/6/2026</a:t>
+              <a:t>7/7/2026</a:t>
             </a:fld>
             <a:endParaRPr lang="en-US"/>
           </a:p>
@@ -2322,7 +2322,7 @@
           <a:p>
             <a:fld id="{1D8BD707-D9CF-40AE-B4C6-C98DA3205C09}" type="datetimeFigureOut">
               <a:rPr lang="en-US" smtClean="0"/>
-              <a:t>7/6/2026</a:t>
+              <a:t>7/7/2026</a:t>
             </a:fld>
             <a:endParaRPr lang="en-US"/>
           </a:p>
@@ -2435,7 +2435,7 @@
           <a:p>
             <a:fld id="{1D8BD707-D9CF-40AE-B4C6-C98DA3205C09}" type="datetimeFigureOut">
               <a:rPr lang="en-US" smtClean="0"/>
-              <a:t>7/6/2026</a:t>
+              <a:t>7/7/2026</a:t>
             </a:fld>
             <a:endParaRPr lang="en-US"/>
           </a:p>
@@ -2746,7 +2746,7 @@
           <a:p>
             <a:fld id="{1D8BD707-D9CF-40AE-B4C6-C98DA3205C09}" type="datetimeFigureOut">
               <a:rPr lang="en-US" smtClean="0"/>
-              <a:t>7/6/2026</a:t>
+              <a:t>7/7/2026</a:t>
             </a:fld>
             <a:endParaRPr lang="en-US"/>
           </a:p>
@@ -3034,7 +3034,7 @@
           <a:p>
             <a:fld id="{1D8BD707-D9CF-40AE-B4C6-C98DA3205C09}" type="datetimeFigureOut">
               <a:rPr lang="en-US" smtClean="0"/>
-              <a:t>7/6/2026</a:t>
+              <a:t>7/7/2026</a:t>
             </a:fld>
             <a:endParaRPr lang="en-US"/>
           </a:p>
@@ -3277,7 +3277,7 @@
             <a:fld id="{1D8BD707-D9CF-40AE-B4C6-C98DA3205C09}" type="datetimeFigureOut">
               <a:rPr lang="en-US" smtClean="0"/>
               <a:pPr/>
-              <a:t>7/6/2026</a:t>
+              <a:t>7/7/2026</a:t>
             </a:fld>
             <a:endParaRPr lang="en-US" dirty="0"/>
           </a:p>
@@ -6598,7 +6598,7 @@
         <p:spPr>
           <a:xfrm>
             <a:off x="1176337" y="2960000"/>
-            <a:ext cx="8500000" cy="5400000"/>
+            <a:ext cx="5529263" cy="5400000"/>
           </a:xfrm>
           <a:prstGeom prst="rect">
             <a:avLst/>
@@ -6797,54 +6797,6 @@
                 <a:sym typeface="Poppins" panose="00000500000000000000"/>
               </a:rPr>
               <a:t>.apk cho Android.</a:t>
-            </a:r>
-          </a:p>
-        </p:txBody>
-      </p:sp>
-      <p:sp>
-        <p:nvSpPr>
-          <p:cNvPr id="304" name="ImgPlaceholder"/>
-          <p:cNvSpPr txBox="1"/>
-          <p:nvPr/>
-        </p:nvSpPr>
-        <p:spPr>
-          <a:xfrm>
-            <a:off x="10100000" y="2920000"/>
-            <a:ext cx="7159300" cy="5600000"/>
-          </a:xfrm>
-          <a:prstGeom prst="roundRect">
-            <a:avLst>
-              <a:gd name="adj" fmla="val 4000"/>
-            </a:avLst>
-          </a:prstGeom>
-          <a:solidFill>
-            <a:srgbClr val="F1F5F9"/>
-          </a:solidFill>
-          <a:ln w="12700" cap="sq">
-            <a:solidFill>
-              <a:srgbClr val="94A3B8"/>
-            </a:solidFill>
-            <a:prstDash val="dash"/>
-          </a:ln>
-        </p:spPr>
-        <p:txBody>
-          <a:bodyPr wrap="square" lIns="91440" tIns="50800" rIns="91440" bIns="50800" rtlCol="0" anchor="ctr"/>
-          <a:lstStyle/>
-          <a:p>
-            <a:pPr algn="ctr">
-              <a:lnSpc>
-                <a:spcPct val="120000"/>
-              </a:lnSpc>
-            </a:pPr>
-            <a:r>
-              <a:rPr lang="vi-VN" sz="1800" dirty="0">
-                <a:solidFill>
-                  <a:srgbClr val="64748B"/>
-                </a:solidFill>
-                <a:latin typeface="Arial" panose="020B0604020202020204" pitchFamily="34" charset="0"/>
-                <a:cs typeface="Arial" panose="020B0604020202020204" pitchFamily="34" charset="0"/>
-              </a:rPr>
-              <a:t>[Hình 3.6 — Sơ đồ triển khai hạ tầng Production]</a:t>
             </a:r>
           </a:p>
         </p:txBody>
@@ -7204,6 +7156,47 @@
           </p:txBody>
         </p:sp>
       </p:grpSp>
+      <p:pic>
+        <p:nvPicPr>
+          <p:cNvPr id="3" name="Picture 2">
+            <a:extLst>
+              <a:ext uri="{FF2B5EF4-FFF2-40B4-BE49-F238E27FC236}">
+                <a16:creationId xmlns:a16="http://schemas.microsoft.com/office/drawing/2014/main" id="{B56CD300-9A31-88D1-5A59-5805B708D663}"/>
+              </a:ext>
+            </a:extLst>
+          </p:cNvPr>
+          <p:cNvPicPr>
+            <a:picLocks noChangeAspect="1"/>
+          </p:cNvPicPr>
+          <p:nvPr/>
+        </p:nvPicPr>
+        <p:blipFill>
+          <a:blip r:embed="rId4" cstate="print">
+            <a:extLst>
+              <a:ext uri="{28A0092B-C50C-407E-A947-70E740481C1C}">
+                <a14:useLocalDpi xmlns:a14="http://schemas.microsoft.com/office/drawing/2010/main" val="0"/>
+              </a:ext>
+            </a:extLst>
+          </a:blip>
+          <a:srcRect/>
+          <a:stretch>
+            <a:fillRect/>
+          </a:stretch>
+        </p:blipFill>
+        <p:spPr bwMode="auto">
+          <a:xfrm>
+            <a:off x="6705600" y="1472210"/>
+            <a:ext cx="11375613" cy="7584790"/>
+          </a:xfrm>
+          <a:prstGeom prst="rect">
+            <a:avLst/>
+          </a:prstGeom>
+          <a:noFill/>
+          <a:ln>
+            <a:noFill/>
+          </a:ln>
+        </p:spPr>
+      </p:pic>
     </p:spTree>
   </p:cSld>
   <p:clrMapOvr>
@@ -12729,7 +12722,7 @@
         <p:spPr>
           <a:xfrm>
             <a:off x="1176337" y="2760000"/>
-            <a:ext cx="16080000" cy="5400000"/>
+            <a:ext cx="7739063" cy="5400000"/>
           </a:xfrm>
           <a:prstGeom prst="rect">
             <a:avLst/>
@@ -12866,54 +12859,6 @@
                 <a:sym typeface="Poppins" panose="00000500000000000000"/>
               </a:rPr>
               <a:t>Điểm khác ứng dụng CRUD thường: mọi request AI đều qua backend kiểm soát.</a:t>
-            </a:r>
-          </a:p>
-        </p:txBody>
-      </p:sp>
-      <p:sp>
-        <p:nvSpPr>
-          <p:cNvPr id="304" name="ImgPlaceholder"/>
-          <p:cNvSpPr txBox="1"/>
-          <p:nvPr/>
-        </p:nvSpPr>
-        <p:spPr>
-          <a:xfrm>
-            <a:off x="1176337" y="4350000"/>
-            <a:ext cx="16080000" cy="4100000"/>
-          </a:xfrm>
-          <a:prstGeom prst="roundRect">
-            <a:avLst>
-              <a:gd name="adj" fmla="val 4000"/>
-            </a:avLst>
-          </a:prstGeom>
-          <a:solidFill>
-            <a:srgbClr val="F1F5F9"/>
-          </a:solidFill>
-          <a:ln w="12700" cap="sq">
-            <a:solidFill>
-              <a:srgbClr val="94A3B8"/>
-            </a:solidFill>
-            <a:prstDash val="dash"/>
-          </a:ln>
-        </p:spPr>
-        <p:txBody>
-          <a:bodyPr wrap="square" lIns="91440" tIns="50800" rIns="91440" bIns="50800" rtlCol="0" anchor="ctr"/>
-          <a:lstStyle/>
-          <a:p>
-            <a:pPr algn="ctr">
-              <a:lnSpc>
-                <a:spcPct val="120000"/>
-              </a:lnSpc>
-            </a:pPr>
-            <a:r>
-              <a:rPr lang="vi-VN" sz="1800" dirty="0">
-                <a:solidFill>
-                  <a:srgbClr val="64748B"/>
-                </a:solidFill>
-                <a:latin typeface="Arial" panose="020B0604020202020204" pitchFamily="34" charset="0"/>
-                <a:cs typeface="Arial" panose="020B0604020202020204" pitchFamily="34" charset="0"/>
-              </a:rPr>
-              <a:t>[Hình 3.1 — Sơ đồ kiến trúc toàn cảnh hệ thống]</a:t>
             </a:r>
           </a:p>
         </p:txBody>
@@ -13309,6 +13254,47 @@
           </p:txBody>
         </p:sp>
       </p:grpSp>
+      <p:pic>
+        <p:nvPicPr>
+          <p:cNvPr id="3" name="Picture 2">
+            <a:extLst>
+              <a:ext uri="{FF2B5EF4-FFF2-40B4-BE49-F238E27FC236}">
+                <a16:creationId xmlns:a16="http://schemas.microsoft.com/office/drawing/2014/main" id="{DDD36D43-8757-98B1-7DFA-652A35B29C07}"/>
+              </a:ext>
+            </a:extLst>
+          </p:cNvPr>
+          <p:cNvPicPr>
+            <a:picLocks noChangeAspect="1"/>
+          </p:cNvPicPr>
+          <p:nvPr/>
+        </p:nvPicPr>
+        <p:blipFill>
+          <a:blip r:embed="rId4" cstate="print">
+            <a:extLst>
+              <a:ext uri="{28A0092B-C50C-407E-A947-70E740481C1C}">
+                <a14:useLocalDpi xmlns:a14="http://schemas.microsoft.com/office/drawing/2010/main" val="0"/>
+              </a:ext>
+            </a:extLst>
+          </a:blip>
+          <a:srcRect/>
+          <a:stretch>
+            <a:fillRect/>
+          </a:stretch>
+        </p:blipFill>
+        <p:spPr bwMode="auto">
+          <a:xfrm>
+            <a:off x="8975803" y="1232727"/>
+            <a:ext cx="8854997" cy="7824274"/>
+          </a:xfrm>
+          <a:prstGeom prst="rect">
+            <a:avLst/>
+          </a:prstGeom>
+          <a:noFill/>
+          <a:ln>
+            <a:noFill/>
+          </a:ln>
+        </p:spPr>
+      </p:pic>
     </p:spTree>
     <p:extLst>
       <p:ext uri="{BB962C8B-B14F-4D97-AF65-F5344CB8AC3E}">
@@ -13508,54 +13494,6 @@
                 <a:sym typeface="Poppins" panose="00000500000000000000"/>
               </a:rPr>
               <a:t>12 ca sử dụng chính, từ đăng ký, học bài, đến các tính năng AI.</a:t>
-            </a:r>
-          </a:p>
-        </p:txBody>
-      </p:sp>
-      <p:sp>
-        <p:nvSpPr>
-          <p:cNvPr id="304" name="ImgPlaceholder"/>
-          <p:cNvSpPr txBox="1"/>
-          <p:nvPr/>
-        </p:nvSpPr>
-        <p:spPr>
-          <a:xfrm>
-            <a:off x="10100000" y="2920000"/>
-            <a:ext cx="7159300" cy="5600000"/>
-          </a:xfrm>
-          <a:prstGeom prst="roundRect">
-            <a:avLst>
-              <a:gd name="adj" fmla="val 4000"/>
-            </a:avLst>
-          </a:prstGeom>
-          <a:solidFill>
-            <a:srgbClr val="F1F5F9"/>
-          </a:solidFill>
-          <a:ln w="12700" cap="sq">
-            <a:solidFill>
-              <a:srgbClr val="94A3B8"/>
-            </a:solidFill>
-            <a:prstDash val="dash"/>
-          </a:ln>
-        </p:spPr>
-        <p:txBody>
-          <a:bodyPr wrap="square" lIns="91440" tIns="50800" rIns="91440" bIns="50800" rtlCol="0" anchor="ctr"/>
-          <a:lstStyle/>
-          <a:p>
-            <a:pPr algn="ctr">
-              <a:lnSpc>
-                <a:spcPct val="120000"/>
-              </a:lnSpc>
-            </a:pPr>
-            <a:r>
-              <a:rPr lang="vi-VN" sz="1800" dirty="0">
-                <a:solidFill>
-                  <a:srgbClr val="64748B"/>
-                </a:solidFill>
-                <a:latin typeface="Arial" panose="020B0604020202020204" pitchFamily="34" charset="0"/>
-                <a:cs typeface="Arial" panose="020B0604020202020204" pitchFamily="34" charset="0"/>
-              </a:rPr>
-              <a:t>[Hình 3.2 — Sơ đồ Use-case]</a:t>
             </a:r>
           </a:p>
         </p:txBody>
@@ -13915,6 +13853,47 @@
           </p:txBody>
         </p:sp>
       </p:grpSp>
+      <p:pic>
+        <p:nvPicPr>
+          <p:cNvPr id="2" name="Picture 1">
+            <a:extLst>
+              <a:ext uri="{FF2B5EF4-FFF2-40B4-BE49-F238E27FC236}">
+                <a16:creationId xmlns:a16="http://schemas.microsoft.com/office/drawing/2014/main" id="{DF37ADA1-2F66-D8AE-9594-78CB3B508ACB}"/>
+              </a:ext>
+            </a:extLst>
+          </p:cNvPr>
+          <p:cNvPicPr>
+            <a:picLocks noChangeAspect="1"/>
+          </p:cNvPicPr>
+          <p:nvPr/>
+        </p:nvPicPr>
+        <p:blipFill>
+          <a:blip r:embed="rId4">
+            <a:extLst>
+              <a:ext uri="{28A0092B-C50C-407E-A947-70E740481C1C}">
+                <a14:useLocalDpi xmlns:a14="http://schemas.microsoft.com/office/drawing/2010/main" val="0"/>
+              </a:ext>
+            </a:extLst>
+          </a:blip>
+          <a:srcRect/>
+          <a:stretch>
+            <a:fillRect/>
+          </a:stretch>
+        </p:blipFill>
+        <p:spPr bwMode="auto">
+          <a:xfrm>
+            <a:off x="9666812" y="1372880"/>
+            <a:ext cx="7772400" cy="7684120"/>
+          </a:xfrm>
+          <a:prstGeom prst="rect">
+            <a:avLst/>
+          </a:prstGeom>
+          <a:noFill/>
+          <a:ln>
+            <a:noFill/>
+          </a:ln>
+        </p:spPr>
+      </p:pic>
     </p:spTree>
   </p:cSld>
   <p:clrMapOvr>

</xml_diff>

<commit_message>
update presentation file with revised content
</commit_message>
<xml_diff>
--- a/BaoCao/kl-da22ttc-nguyenhuynhphuvinh-110122203-linvnix.pptx
+++ b/BaoCao/kl-da22ttc-nguyenhuynhphuvinh-110122203-linvnix.pptx
@@ -3782,7 +3782,7 @@
                 <a:cs typeface="Arial" panose="020B0604020202020204" pitchFamily="34" charset="0"/>
                 <a:sym typeface="Poppins Bold" panose="00000800000000000000"/>
               </a:rPr>
-              <a:t>ỨNG DỤNG HỖ TRỢ </a:t>
+              <a:t xml:space="preserve">ỨNG DỤNG HỖ TRỢ </a:t>
             </a:r>
             <a:endParaRPr lang="en-US" altLang="en-US" sz="6000" b="1" dirty="0">
               <a:solidFill>
@@ -3810,7 +3810,7 @@
                 <a:cs typeface="Arial" panose="020B0604020202020204" pitchFamily="34" charset="0"/>
                 <a:sym typeface="Poppins Bold" panose="00000800000000000000"/>
               </a:rPr>
-              <a:t>DẠY HỌC TIẾNG VIỆT </a:t>
+              <a:t xml:space="preserve">DẠY HỌC TIẾNG VIỆT </a:t>
             </a:r>
             <a:endParaRPr lang="en-US" altLang="en-US" sz="6000" b="1" dirty="0">
               <a:solidFill>
@@ -3910,7 +3910,7 @@
                 <a:cs typeface="Arial" panose="020B0604020202020204" pitchFamily="34" charset="0"/>
                 <a:sym typeface="Poppins Semi-Bold" panose="00000700000000000000"/>
               </a:rPr>
-              <a:t> Nguyễn Huỳnh </a:t>
+              <a:t xml:space="preserve"> Nguyễn Huỳnh </a:t>
             </a:r>
             <a:r>
               <a:rPr lang="en-US" altLang="en-US" dirty="0" err="1">
@@ -3934,7 +3934,7 @@
                 <a:cs typeface="Arial" panose="020B0604020202020204" pitchFamily="34" charset="0"/>
                 <a:sym typeface="Poppins Semi-Bold" panose="00000700000000000000"/>
               </a:rPr>
-              <a:t> Vinh</a:t>
+              <a:t xml:space="preserve"> Vinh</a:t>
             </a:r>
             <a:endParaRPr lang="vi-VN" altLang="en-US" dirty="0">
               <a:solidFill>
@@ -3974,7 +3974,7 @@
                 <a:cs typeface="Arial" panose="020B0604020202020204" pitchFamily="34" charset="0"/>
                 <a:sym typeface="Poppins Semi-Bold" panose="00000700000000000000"/>
               </a:rPr>
-              <a:t> DA22TTC</a:t>
+              <a:t xml:space="preserve"> DA22TTC</a:t>
             </a:r>
             <a:endParaRPr lang="vi-VN" altLang="en-US" dirty="0">
               <a:solidFill>
@@ -4014,7 +4014,7 @@
                 <a:cs typeface="Arial" panose="020B0604020202020204" pitchFamily="34" charset="0"/>
                 <a:sym typeface="Poppins Semi-Bold" panose="00000700000000000000"/>
               </a:rPr>
-              <a:t> 110122203</a:t>
+              <a:t xml:space="preserve"> 110122203</a:t>
             </a:r>
             <a:endParaRPr lang="vi-VN" altLang="en-US" dirty="0">
               <a:solidFill>
@@ -4552,7 +4552,7 @@
                 <a:cs typeface="Arial" panose="020B0604020202020204" pitchFamily="34" charset="0"/>
                 <a:sym typeface="Poppins Bold" panose="00000800000000000000"/>
               </a:rPr>
-              <a:t>Quy trình Khám phá ảnh</a:t>
+              <a:t>Hệ thống Khám phá ảnh</a:t>
             </a:r>
           </a:p>
         </p:txBody>
@@ -4598,7 +4598,7 @@
                 <a:cs typeface="Arial" panose="020B0604020202020204" pitchFamily="34" charset="0"/>
                 <a:sym typeface="Poppins" panose="00000500000000000000"/>
               </a:rPr>
-              <a:t>Học viên gửi tối đa 5 ảnh kèm một câu hỏi, có thể hỏi tiếp.</a:t>
+              <a:t>Học viên gửi 1 đến 5 ảnh kèm một câu hỏi, định dạng jpeg, png hoặc webp.</a:t>
             </a:r>
           </a:p>
           <a:p>
@@ -4624,7 +4624,7 @@
                 <a:cs typeface="Arial" panose="020B0604020202020204" pitchFamily="34" charset="0"/>
                 <a:sym typeface="Poppins" panose="00000500000000000000"/>
               </a:rPr>
-              <a:t>AI đọc cả ảnh và câu hỏi cùng lúc, trả lời trọn vẹn một lần.</a:t>
+              <a:t>Ảnh chỉ đưa cho AI đọc và không lưu vào hệ thống.</a:t>
             </a:r>
           </a:p>
           <a:p>
@@ -4650,7 +4650,7 @@
                 <a:cs typeface="Arial" panose="020B0604020202020204" pitchFamily="34" charset="0"/>
                 <a:sym typeface="Poppins" panose="00000500000000000000"/>
               </a:rPr>
-              <a:t>Kết quả gồm lời giải thích và danh sách từ vựng: từ, nghĩa, ví dụ.</a:t>
+              <a:t>Câu trả lời của AI đúng theo một khuôn định sẵn là buộc phải có danh sách từ vựng thấy được trong ảnh đi kèm và hiển thị ra giao diện cho học viên.</a:t>
             </a:r>
           </a:p>
           <a:p>
@@ -4676,7 +4676,7 @@
                 <a:cs typeface="Arial" panose="020B0604020202020204" pitchFamily="34" charset="0"/>
                 <a:sym typeface="Poppins" panose="00000500000000000000"/>
               </a:rPr>
-              <a:t>Từ vựng không tự lưu, học viên bấm chọn để đưa vào Yêu sách.</a:t>
+              <a:t>Từ vựng không tự lưu, học viên bấm chọn từng từ để lưu.</a:t>
             </a:r>
           </a:p>
         </p:txBody>
@@ -5211,7 +5211,7 @@
                 <a:cs typeface="Arial" panose="020B0604020202020204" pitchFamily="34" charset="0"/>
                 <a:sym typeface="Poppins Bold" panose="00000800000000000000"/>
               </a:rPr>
-              <a:t>Quy trình Sinh bài tập tùy chỉnh</a:t>
+              <a:t>Hệ thống Sinh bài tập tùy chỉnh</a:t>
             </a:r>
           </a:p>
         </p:txBody>
@@ -5257,7 +5257,7 @@
                 <a:cs typeface="Arial" panose="020B0604020202020204" pitchFamily="34" charset="0"/>
                 <a:sym typeface="Poppins" panose="00000500000000000000"/>
               </a:rPr>
-              <a:t>Chọn số câu, dạng câu hỏi, trọng tâm ôn tập, và phạm vi ôn.</a:t>
+              <a:t>Học viên chọn tối đa 30 câu, chọn 1 hoặc nhiều dạng trong 5 dạng: trắc nghiệm, điền vào chỗ trống, ghép cặp, sắp xếp, dịch câu (không có dạng nghe và nói), chọn ôn từ vựng, ngữ pháp hay cả hai, ghi thêm yêu cầu riêng không quá 500 chữ.</a:t>
             </a:r>
           </a:p>
           <a:p>
@@ -5283,7 +5283,7 @@
                 <a:cs typeface="Arial" panose="020B0604020202020204" pitchFamily="34" charset="0"/>
                 <a:sym typeface="Poppins" panose="00000500000000000000"/>
               </a:rPr>
-              <a:t>Phạm vi là một bài học, một chủ đề, hoặc cả một khóa học.</a:t>
+              <a:t>Bắt buộc chọn đúng một phạm vi: một bài học, một chủ đề, hoặc cả một khóa học. Ôn theo chủ đề hoặc khóa học thì phải học xong ít nhất một phần trong đó.</a:t>
             </a:r>
           </a:p>
           <a:p>
@@ -5309,7 +5309,7 @@
                 <a:cs typeface="Arial" panose="020B0604020202020204" pitchFamily="34" charset="0"/>
                 <a:sym typeface="Poppins" panose="00000500000000000000"/>
               </a:rPr>
-              <a:t>AI chỉ dựa vào phần đã học trong phạm vi đó để ra đề.</a:t>
+              <a:t>Hệ thống tự gom từ vựng, ngữ pháp và nội dung học viên đã hoàn thành trong phạm vi đó, AI chỉ được ra đề trong phần này.</a:t>
             </a:r>
           </a:p>
           <a:p>
@@ -5335,33 +5335,7 @@
                 <a:cs typeface="Arial" panose="020B0604020202020204" pitchFamily="34" charset="0"/>
                 <a:sym typeface="Poppins" panose="00000500000000000000"/>
               </a:rPr>
-              <a:t>Màn hình báo đang tạo đề, xong thì chuyển sang sẵn sàng làm bài.</a:t>
-            </a:r>
-          </a:p>
-          <a:p>
-            <a:pPr marL="457200" indent="-457200" algn="l">
-              <a:lnSpc>
-                <a:spcPct val="118000"/>
-              </a:lnSpc>
-              <a:spcBef>
-                <a:spcPts val="500"/>
-              </a:spcBef>
-              <a:spcAft>
-                <a:spcPts val="500"/>
-              </a:spcAft>
-              <a:buFont typeface="Arial"/>
-              <a:buAutoNum type="arabicPeriod"/>
-            </a:pPr>
-            <a:r>
-              <a:rPr lang="vi-VN" sz="2100" dirty="0">
-                <a:solidFill>
-                  <a:srgbClr val="1F2937"/>
-                </a:solidFill>
-                <a:latin typeface="Arial" panose="020B0604020202020204" pitchFamily="34" charset="0"/>
-                <a:cs typeface="Arial" panose="020B0604020202020204" pitchFamily="34" charset="0"/>
-                <a:sym typeface="Poppins" panose="00000500000000000000"/>
-              </a:rPr>
-              <a:t>Muốn đổi đề, bấm tạo lại: có bộ mới rồi mới thay bộ cũ.</a:t>
+              <a:t>Mỗi câu AI soạn ra phải kiểm tra đủ đáp án và đúng định dạng trước khi lưu, sai thì tự tạo lại.</a:t>
             </a:r>
           </a:p>
         </p:txBody>
@@ -5977,7 +5951,7 @@
                 <a:cs typeface="Arial" panose="020B0604020202020204" pitchFamily="34" charset="0"/>
                 <a:sym typeface="Poppins" panose="00000500000000000000"/>
               </a:rPr>
-              <a:t>PostgreSQL, 27 bảng chia 6 nhóm nghiệp vụ.</a:t>
+              <a:t>PostgreSQL, 27 bảng, gom theo 6 nhóm nghiệp vụ.</a:t>
             </a:r>
           </a:p>
           <a:p>
@@ -6003,7 +5977,7 @@
                 <a:cs typeface="Arial" panose="020B0604020202020204" pitchFamily="34" charset="0"/>
                 <a:sym typeface="Poppins" panose="00000500000000000000"/>
               </a:rPr>
-              <a:t>6 nhóm nghiệp vụ, chú thích màu riêng theo từng nhóm trên sơ đồ.</a:t>
+              <a:t>6 nhóm: Tài khoản và Xác thực, Học liệu, Luyện tập, Tiến trình và Mục tiêu, Tương tác AI, Hội thoại mô phỏng.</a:t>
             </a:r>
           </a:p>
           <a:p>
@@ -6029,7 +6003,7 @@
                 <a:cs typeface="Arial" panose="020B0604020202020204" pitchFamily="34" charset="0"/>
                 <a:sym typeface="Poppins" panose="00000500000000000000"/>
               </a:rPr>
-              <a:t>Mọi bảng đều có mã định danh riêng và thời điểm tạo, sửa, xóa mềm.</a:t>
+              <a:t>Bảng nào cũng có id, thời điểm tạo, sửa và cờ xóa mềm.</a:t>
             </a:r>
           </a:p>
           <a:p>
@@ -6055,7 +6029,7 @@
                 <a:cs typeface="Arial" panose="020B0604020202020204" pitchFamily="34" charset="0"/>
                 <a:sym typeface="Poppins" panose="00000500000000000000"/>
               </a:rPr>
-              <a:t>Dữ liệu linh hoạt như cấu hình bài tập, kết quả AI lưu dạng JSON.</a:t>
+              <a:t>Cấu hình bài tập và kết quả AI lưu dạng JSON để thêm dạng câu hỏi mới mà không phải sửa lại cấu trúc bảng.</a:t>
             </a:r>
           </a:p>
         </p:txBody>
@@ -6719,7 +6693,7 @@
                 <a:cs typeface="Arial" panose="020B0604020202020204" pitchFamily="34" charset="0"/>
                 <a:sym typeface="Poppins" panose="00000500000000000000"/>
               </a:rPr>
-              <a:t> </a:t>
+              <a:t xml:space="preserve"> </a:t>
             </a:r>
             <a:r>
               <a:rPr lang="en-US" sz="2100" dirty="0" err="1">
@@ -6741,7 +6715,7 @@
                 <a:cs typeface="Arial" panose="020B0604020202020204" pitchFamily="34" charset="0"/>
                 <a:sym typeface="Poppins" panose="00000500000000000000"/>
               </a:rPr>
-              <a:t> </a:t>
+              <a:t xml:space="preserve"> </a:t>
             </a:r>
             <a:r>
               <a:rPr lang="en-US" sz="2100" dirty="0" err="1">
@@ -6763,7 +6737,7 @@
                 <a:cs typeface="Arial" panose="020B0604020202020204" pitchFamily="34" charset="0"/>
                 <a:sym typeface="Poppins" panose="00000500000000000000"/>
               </a:rPr>
-              <a:t> Cloudflare Pages</a:t>
+              <a:t xml:space="preserve"> Cloudflare Pages</a:t>
             </a:r>
             <a:r>
               <a:rPr lang="vi-VN" sz="2100" dirty="0">
@@ -6774,7 +6748,7 @@
                 <a:cs typeface="Arial" panose="020B0604020202020204" pitchFamily="34" charset="0"/>
                 <a:sym typeface="Poppins" panose="00000500000000000000"/>
               </a:rPr>
-              <a:t>, di động biên dịch </a:t>
+              <a:t xml:space="preserve">, di động biên dịch </a:t>
             </a:r>
             <a:r>
               <a:rPr lang="en-US" sz="2100" dirty="0">
@@ -6785,7 +6759,7 @@
                 <a:cs typeface="Arial" panose="020B0604020202020204" pitchFamily="34" charset="0"/>
                 <a:sym typeface="Poppins" panose="00000500000000000000"/>
               </a:rPr>
-              <a:t>file </a:t>
+              <a:t xml:space="preserve">file </a:t>
             </a:r>
             <a:r>
               <a:rPr lang="vi-VN" sz="2100" dirty="0">
@@ -7860,7 +7834,7 @@
                 <a:cs typeface="Arial" panose="020B0604020202020204" pitchFamily="34" charset="0"/>
                 <a:sym typeface="Poppins" panose="00000500000000000000"/>
               </a:rPr>
-              <a:t>Đánh giá phát âm, </a:t>
+              <a:t xml:space="preserve">Đánh giá phát âm, </a:t>
             </a:r>
             <a:r>
               <a:rPr lang="en-US" sz="2000" dirty="0" err="1">
@@ -7882,7 +7856,7 @@
                 <a:cs typeface="Arial" panose="020B0604020202020204" pitchFamily="34" charset="0"/>
                 <a:sym typeface="Poppins" panose="00000500000000000000"/>
               </a:rPr>
-              <a:t> </a:t>
+              <a:t xml:space="preserve"> </a:t>
             </a:r>
             <a:r>
               <a:rPr lang="en-US" sz="2000" dirty="0" err="1">
@@ -7904,7 +7878,7 @@
                 <a:cs typeface="Arial" panose="020B0604020202020204" pitchFamily="34" charset="0"/>
                 <a:sym typeface="Poppins" panose="00000500000000000000"/>
               </a:rPr>
-              <a:t> </a:t>
+              <a:t xml:space="preserve"> </a:t>
             </a:r>
             <a:r>
               <a:rPr lang="en-US" sz="2000" dirty="0" err="1">
@@ -7926,7 +7900,7 @@
                 <a:cs typeface="Arial" panose="020B0604020202020204" pitchFamily="34" charset="0"/>
                 <a:sym typeface="Poppins" panose="00000500000000000000"/>
               </a:rPr>
-              <a:t> </a:t>
+              <a:t xml:space="preserve"> </a:t>
             </a:r>
             <a:r>
               <a:rPr lang="en-US" sz="2000" dirty="0" err="1">
@@ -8752,7 +8726,7 @@
             </a:pPr>
             <a:r>
               <a:rPr lang="vi-VN"/>
-              <a:t> </a:t>
+              <a:t xml:space="preserve"> </a:t>
             </a:r>
           </a:p>
         </p:txBody>
@@ -9897,7 +9871,7 @@
                 <a:cs typeface="Arial" panose="020B0604020202020204" pitchFamily="34" charset="0"/>
                 <a:sym typeface="+mn-ea"/>
               </a:rPr>
-              <a:t>Lý do chọn đề tài, mục tiêu, đặc trưng tiếng Việt, nền tảng AI sử dụng.</a:t>
+              <a:t>Đề tài, tiếng Việt và CEFR, nền tảng AI.</a:t>
             </a:r>
           </a:p>
         </p:txBody>
@@ -10109,7 +10083,7 @@
                 <a:latin typeface="Arial" panose="020B0604020202020204" pitchFamily="34" charset="0"/>
                 <a:cs typeface="Arial" panose="020B0604020202020204" pitchFamily="34" charset="0"/>
               </a:rPr>
-              <a:t>Kiến trúc, 4 tính năng AI, cơ sở dữ liệu.</a:t>
+              <a:t>Kiến trúc, đối tượng sử dụng, 4 tính năng AI, CSDL, triển khai.</a:t>
             </a:r>
           </a:p>
         </p:txBody>
@@ -10189,7 +10163,7 @@
                 <a:latin typeface="Arial" panose="020B0604020202020204" pitchFamily="34" charset="0"/>
                 <a:cs typeface="Arial" panose="020B0604020202020204" pitchFamily="34" charset="0"/>
               </a:rPr>
-              <a:t>Kết quả đạt được, hướng phát triển, demo trực tiếp.</a:t>
+              <a:t>Kết quả, hướng phát triển, demo.</a:t>
             </a:r>
           </a:p>
         </p:txBody>
@@ -10230,7 +10204,7 @@
                 <a:cs typeface="Arial" panose="020B0604020202020204" pitchFamily="34" charset="0"/>
                 <a:sym typeface="Poppins Bold" panose="00000800000000000000"/>
               </a:rPr>
-              <a:t>Kết quả </a:t>
+              <a:t xml:space="preserve">Kết quả </a:t>
             </a:r>
             <a:r>
               <a:rPr lang="en-US" altLang="en-US" sz="2400" dirty="0" err="1">
@@ -10254,7 +10228,7 @@
                 <a:cs typeface="Arial" panose="020B0604020202020204" pitchFamily="34" charset="0"/>
                 <a:sym typeface="Poppins Bold" panose="00000800000000000000"/>
               </a:rPr>
-              <a:t> Demo</a:t>
+              <a:t xml:space="preserve"> Demo</a:t>
             </a:r>
           </a:p>
         </p:txBody>
@@ -11418,7 +11392,7 @@
                 <a:cs typeface="Arial" panose="020B0604020202020204" pitchFamily="34" charset="0"/>
                 <a:sym typeface="Poppins" panose="00000500000000000000"/>
               </a:rPr>
-              <a:t>6 thanh điệu; đổi thanh là đổi nghĩa, ví dụ "vở" và "vợ".</a:t>
+              <a:t>6 thanh điệu, đổi thanh là đổi nghĩa: "ma, má, mà, mả, mã, mạ".</a:t>
             </a:r>
           </a:p>
           <a:p>
@@ -11444,7 +11418,7 @@
                 <a:cs typeface="Arial" panose="020B0604020202020204" pitchFamily="34" charset="0"/>
                 <a:sym typeface="Poppins" panose="00000500000000000000"/>
               </a:rPr>
-              <a:t>3 vùng phương ngữ Bắc, Trung, Nam, khác nhau chủ yếu ở ngữ âm.</a:t>
+              <a:t>3 vùng phương ngữ Bắc, Trung, Nam, khác nhau chủ yếu ở phát âm.</a:t>
             </a:r>
           </a:p>
           <a:p>
@@ -11470,7 +11444,7 @@
                 <a:cs typeface="Arial" panose="020B0604020202020204" pitchFamily="34" charset="0"/>
                 <a:sym typeface="Poppins" panose="00000500000000000000"/>
               </a:rPr>
-              <a:t>Lỗi thường gặp: thanh điệu, phụ âm, danh từ phân loại, trật tự từ.</a:t>
+              <a:t>Người học hay sai: thanh điệu, phụ âm cuối, loại từ, trật tự từ.</a:t>
             </a:r>
           </a:p>
         </p:txBody>
@@ -12008,7 +11982,7 @@
                 <a:cs typeface="Arial" panose="020B0604020202020204" pitchFamily="34" charset="0"/>
                 <a:sym typeface="Poppins Bold" panose="00000800000000000000"/>
               </a:rPr>
-              <a:t>Nền tảng AI: từ chatbot đến Agent</a:t>
+              <a:t>AI Agent và vòng ReAct</a:t>
             </a:r>
           </a:p>
         </p:txBody>
@@ -12054,7 +12028,7 @@
                 <a:cs typeface="Arial" panose="020B0604020202020204" pitchFamily="34" charset="0"/>
                 <a:sym typeface="Poppins" panose="00000500000000000000"/>
               </a:rPr>
-              <a:t>Chatbot thường không biết tiến trình học của từng học viên.</a:t>
+              <a:t>Chatbot chỉ trả lời bằng dữ liệu đã học, không đọc được dữ liệu người dùng.</a:t>
             </a:r>
           </a:p>
           <a:p>
@@ -12080,7 +12054,7 @@
                 <a:cs typeface="Arial" panose="020B0604020202020204" pitchFamily="34" charset="0"/>
                 <a:sym typeface="Poppins" panose="00000500000000000000"/>
               </a:rPr>
-              <a:t>Agent được gọi công cụ để đọc dữ liệu thật trước khi trả lời.</a:t>
+              <a:t>Agent được cấp công cụ, tự chọn gọi công cụ khi cần dữ liệu thật.</a:t>
             </a:r>
           </a:p>
           <a:p>
@@ -12106,7 +12080,7 @@
                 <a:cs typeface="Arial" panose="020B0604020202020204" pitchFamily="34" charset="0"/>
                 <a:sym typeface="Poppins" panose="00000500000000000000"/>
               </a:rPr>
-              <a:t>Cơ sở lý thuyết: suy luận, hành động, quan sát kết quả, gọi là ReAct.</a:t>
+              <a:t>ReAct: Suy luận → Gọi công cụ → Quan sát kết quả → lặp cho tới khi trả lời.</a:t>
             </a:r>
           </a:p>
           <a:p>
@@ -12132,7 +12106,7 @@
                 <a:cs typeface="Arial" panose="020B0604020202020204" pitchFamily="34" charset="0"/>
                 <a:sym typeface="Poppins" panose="00000500000000000000"/>
               </a:rPr>
-              <a:t>Nguyên tắc an toàn: công cụ chỉ được đọc, không tự sửa hoặc xóa dữ liệu.</a:t>
+              <a:t>Là nền cho Trợ lý AI, biết tra đúng tiến độ của từng học viên.</a:t>
             </a:r>
           </a:p>
         </p:txBody>
@@ -12780,7 +12754,7 @@
                 <a:cs typeface="Arial" panose="020B0604020202020204" pitchFamily="34" charset="0"/>
                 <a:sym typeface="Poppins" panose="00000500000000000000"/>
               </a:rPr>
-              <a:t>Client: mobile Flutter (Riverpod), admin React (Zustand, TanStack Query).</a:t>
+              <a:t>Client: mobile Flutter, admin React, đều có thư viện quản lý trạng thái và bộ nhớ đệm dữ liệu.</a:t>
             </a:r>
           </a:p>
           <a:p>
@@ -12806,7 +12780,7 @@
                 <a:cs typeface="Arial" panose="020B0604020202020204" pitchFamily="34" charset="0"/>
                 <a:sym typeface="Poppins" panose="00000500000000000000"/>
               </a:rPr>
-              <a:t>Server: NestJS chạy trên Bun, guard/pipe/interceptor xử lý xác thực và phân quyền.</a:t>
+              <a:t>Server: NestJS chạy trên Bun, các lớp trung gian lo xác thực, kiểm tra dữ liệu vào, gắn log.</a:t>
             </a:r>
           </a:p>
           <a:p>
@@ -12833,32 +12807,6 @@
                 <a:sym typeface="Poppins" panose="00000500000000000000"/>
               </a:rPr>
               <a:t>Data và dịch vụ ngoài: PostgreSQL, Redis, Google OAuth, nhà cung cấp AI.</a:t>
-            </a:r>
-          </a:p>
-          <a:p>
-            <a:pPr marL="457200" indent="-457200" algn="l">
-              <a:lnSpc>
-                <a:spcPct val="118000"/>
-              </a:lnSpc>
-              <a:spcBef>
-                <a:spcPts val="500"/>
-              </a:spcBef>
-              <a:spcAft>
-                <a:spcPts val="500"/>
-              </a:spcAft>
-              <a:buFont typeface="Arial"/>
-              <a:buAutoNum type="arabicPeriod"/>
-            </a:pPr>
-            <a:r>
-              <a:rPr lang="vi-VN" sz="2000" dirty="0">
-                <a:solidFill>
-                  <a:srgbClr val="1F2937"/>
-                </a:solidFill>
-                <a:latin typeface="Arial" panose="020B0604020202020204" pitchFamily="34" charset="0"/>
-                <a:cs typeface="Arial" panose="020B0604020202020204" pitchFamily="34" charset="0"/>
-                <a:sym typeface="Poppins" panose="00000500000000000000"/>
-              </a:rPr>
-              <a:t>Điểm khác ứng dụng CRUD thường: mọi request AI đều qua backend kiểm soát.</a:t>
             </a:r>
           </a:p>
         </p:txBody>
@@ -13493,7 +13441,33 @@
                 <a:cs typeface="Arial" panose="020B0604020202020204" pitchFamily="34" charset="0"/>
                 <a:sym typeface="Poppins" panose="00000500000000000000"/>
               </a:rPr>
-              <a:t>12 ca sử dụng chính, từ đăng ký, học bài, đến các tính năng AI.</a:t>
+              <a:t>9 ca của Học viên: đăng ký/đăng nhập, đặt mục tiêu ngày, học bài, hỏi Trợ lý AI, làm bài tập, sinh bài tập tùy chỉnh, khám phá ảnh, lưu từ vựng cá nhân, hội thoại mô phỏng.</a:t>
+            </a:r>
+          </a:p>
+          <a:p>
+            <a:pPr marL="457200" indent="-457200" algn="l">
+              <a:lnSpc>
+                <a:spcPct val="118000"/>
+              </a:lnSpc>
+              <a:spcBef>
+                <a:spcPts val="500"/>
+              </a:spcBef>
+              <a:spcAft>
+                <a:spcPts val="500"/>
+              </a:spcAft>
+              <a:buFont typeface="Arial"/>
+              <a:buAutoNum type="arabicPeriod"/>
+            </a:pPr>
+            <a:r>
+              <a:rPr lang="vi-VN" sz="2100" dirty="0">
+                <a:solidFill>
+                  <a:srgbClr val="1F2937"/>
+                </a:solidFill>
+                <a:latin typeface="Arial" panose="020B0604020202020204" pitchFamily="34" charset="0"/>
+                <a:cs typeface="Arial" panose="020B0604020202020204" pitchFamily="34" charset="0"/>
+                <a:sym typeface="Poppins" panose="00000500000000000000"/>
+              </a:rPr>
+              <a:t>3 ca của Quản trị viên: soạn khóa học/chủ đề/bài học, soạn từ vựng/ngữ pháp/bài tập, quản lý tình huống mô phỏng.</a:t>
             </a:r>
           </a:p>
         </p:txBody>
@@ -14015,7 +13989,7 @@
                 <a:cs typeface="Arial" panose="020B0604020202020204" pitchFamily="34" charset="0"/>
                 <a:sym typeface="Poppins Bold" panose="00000800000000000000"/>
               </a:rPr>
-              <a:t>Quy trình Trợ lý AI</a:t>
+              <a:t>Hệ thống Trợ lý AI</a:t>
             </a:r>
           </a:p>
         </p:txBody>
@@ -14061,7 +14035,7 @@
                 <a:cs typeface="Arial" panose="020B0604020202020204" pitchFamily="34" charset="0"/>
                 <a:sym typeface="Poppins" panose="00000500000000000000"/>
               </a:rPr>
-              <a:t>9 công cụ hỗ trợ, tất cả chỉ đọc dữ liệu của đúng người đang hỏi.</a:t>
+              <a:t>Học viên gõ câu hỏi, hệ thống gắn kèm ngữ cảnh màn hình đang xem vào AI.</a:t>
             </a:r>
           </a:p>
           <a:p>
@@ -14087,7 +14061,7 @@
                 <a:cs typeface="Arial" panose="020B0604020202020204" pitchFamily="34" charset="0"/>
                 <a:sym typeface="Poppins" panose="00000500000000000000"/>
               </a:rPr>
-              <a:t>AI chỉ được chọn dùng công cụ ở lượt gọi đầu tiên, tối đa 10 lượt.</a:t>
+              <a:t>Lượt AI đầu tiên tự quyết có gọi công cụ hay không, tối đa gọi liên tục 10 lượt.</a:t>
             </a:r>
           </a:p>
           <a:p>
@@ -14113,7 +14087,7 @@
                 <a:cs typeface="Arial" panose="020B0604020202020204" pitchFamily="34" charset="0"/>
                 <a:sym typeface="Poppins" panose="00000500000000000000"/>
               </a:rPr>
-              <a:t>Cần nhiều công cụ thì chạy lần lượt từng cái, không chạy cùng lúc.</a:t>
+              <a:t>9 công cụ chỉ đọc, tự khóa theo đúng người đang hỏi: Báo trạng thái, Hồ sơ học viên, Tiến độ học, Kết quả bài tập gần đây, Từ đã lưu, Tra từ vựng, Tra ngữ pháp, Tìm bài học, Chi tiết bài học.</a:t>
             </a:r>
           </a:p>
           <a:p>
@@ -14139,7 +14113,7 @@
                 <a:cs typeface="Arial" panose="020B0604020202020204" pitchFamily="34" charset="0"/>
                 <a:sym typeface="Poppins" panose="00000500000000000000"/>
               </a:rPr>
-              <a:t>Trả lời hiện dần từng chữ, kèm báo trạng thái khi đang dùng công cụ.</a:t>
+              <a:t>Nhiều công cụ chạy lần lượt, gộp hết kết quả rồi AI mới viết trả lời.</a:t>
             </a:r>
           </a:p>
           <a:p>
@@ -14165,7 +14139,7 @@
                 <a:cs typeface="Arial" panose="020B0604020202020204" pitchFamily="34" charset="0"/>
                 <a:sym typeface="Poppins" panose="00000500000000000000"/>
               </a:rPr>
-              <a:t>Bấm Dừng hủy thẳng yêu cầu đang gửi tới AI, giữ lại phần đã trả lời.</a:t>
+              <a:t>Đang làm bài tập, AI nhìn trạng thái để chọn cách hướng dẫn: chưa trả lời thì gợi ý cách nghĩ, trả lời sai thì nhận xét góp ý, không nói thẳng đáp án.</a:t>
             </a:r>
           </a:p>
         </p:txBody>
@@ -14700,7 +14674,7 @@
                 <a:cs typeface="Arial" panose="020B0604020202020204" pitchFamily="34" charset="0"/>
                 <a:sym typeface="Poppins Bold" panose="00000800000000000000"/>
               </a:rPr>
-              <a:t>Quy trình Hội thoại mô phỏng</a:t>
+              <a:t>Hệ thống Hội thoại mô phỏng</a:t>
             </a:r>
           </a:p>
         </p:txBody>
@@ -14746,7 +14720,7 @@
                 <a:cs typeface="Arial" panose="020B0604020202020204" pitchFamily="34" charset="0"/>
                 <a:sym typeface="Poppins" panose="00000500000000000000"/>
               </a:rPr>
-              <a:t>Có sẵn lời mở đầu thì hiện luôn, AI chỉ vào việc từ câu học viên gõ.</a:t>
+              <a:t>Mỗi lượt học viên nói, hệ thống gọi AI đúng một lần, AI tự chọn nhân vật nào cần trả lời theo đúng thứ tự hội thoại.</a:t>
             </a:r>
           </a:p>
           <a:p>
@@ -14772,7 +14746,7 @@
                 <a:cs typeface="Arial" panose="020B0604020202020204" pitchFamily="34" charset="0"/>
                 <a:sym typeface="Poppins" panose="00000500000000000000"/>
               </a:rPr>
-              <a:t>Mỗi lượt học viên nói, hệ thống chỉ gọi AI đúng một lần duy nhất.</a:t>
+              <a:t>Ngay sau câu học viên, AI chấm lỗi chính tả và ngữ pháp ngay trong câu, ghi đoạn sai, đoạn sửa, loại lỗi và góp ý.</a:t>
             </a:r>
           </a:p>
           <a:p>
@@ -14798,7 +14772,7 @@
                 <a:cs typeface="Arial" panose="020B0604020202020204" pitchFamily="34" charset="0"/>
                 <a:sym typeface="Poppins" panose="00000500000000000000"/>
               </a:rPr>
-              <a:t>AI chấm lỗi chính tả và ngữ pháp ngay trong câu, lưu kèm tin nhắn đó.</a:t>
+              <a:t>Phiên kết thúc vì 1 trong 4 lý do, mỗi lý do có hướng dẫn chấm điểm riêng: hoàn thành trọn vẹn, sai quá nhiều liên tục, dùng lời không phù hợp, dùng lời xúc phạm.</a:t>
             </a:r>
           </a:p>
           <a:p>
@@ -14824,33 +14798,7 @@
                 <a:cs typeface="Arial" panose="020B0604020202020204" pitchFamily="34" charset="0"/>
                 <a:sym typeface="Poppins" panose="00000500000000000000"/>
               </a:rPr>
-              <a:t>Kết thúc phiên vì 1 trong 4 lý do, mỗi lý do chấm điểm khác nhau.</a:t>
-            </a:r>
-          </a:p>
-          <a:p>
-            <a:pPr marL="457200" indent="-457200" algn="l">
-              <a:lnSpc>
-                <a:spcPct val="118000"/>
-              </a:lnSpc>
-              <a:spcBef>
-                <a:spcPts val="500"/>
-              </a:spcBef>
-              <a:spcAft>
-                <a:spcPts val="500"/>
-              </a:spcAft>
-              <a:buFont typeface="Arial"/>
-              <a:buAutoNum type="arabicPeriod"/>
-            </a:pPr>
-            <a:r>
-              <a:rPr lang="vi-VN" sz="2100" dirty="0">
-                <a:solidFill>
-                  <a:srgbClr val="1F2937"/>
-                </a:solidFill>
-                <a:latin typeface="Arial" panose="020B0604020202020204" pitchFamily="34" charset="0"/>
-                <a:cs typeface="Arial" panose="020B0604020202020204" pitchFamily="34" charset="0"/>
-                <a:sym typeface="Poppins" panose="00000500000000000000"/>
-              </a:rPr>
-              <a:t>Điểm từng tiêu chí do AI chấm, hệ thống đối chiếu lại trước khi tính tổng.</a:t>
+              <a:t>Điểm từng tiêu chí do AI chấm theo thang 0 đến 100, hệ thống đối chiếu lại tên tiêu chí rồi tính tổng theo trọng số.</a:t>
             </a:r>
           </a:p>
         </p:txBody>

</xml_diff>